<commit_message>
Add submission README and screenshots
</commit_message>
<xml_diff>
--- a/광주_3반_박건우_지역병원길잡이_발표.pptx
+++ b/광주_3반_박건우_지역병원길잡이_발표.pptx
@@ -5074,7 +5074,7 @@
                 </a:solidFill>
                 <a:latin typeface="Malgun Gothic"/>
               </a:rPr>
-              <a:t>샘플 데이터 — 공공데이터포털 표준데이터로 교체 + 영업상태 필터·주기 갱신 필요</a:t>
+              <a:t>공공 API 의존성 — 인증키·네트워크·호출량 제한이 있어 CSV fallback을 유지</a:t>
             </a:r>
           </a:p>
           <a:p>
@@ -5090,7 +5090,7 @@
                 </a:solidFill>
                 <a:latin typeface="Malgun Gothic"/>
               </a:rPr>
-              <a:t>실시간 응급실 정보 부재 — 중앙응급의료센터(E-gen) 실시간 병상 API 연동이 다음 단계</a:t>
+              <a:t>데이터 완전성 한계 — API 반경·페이지 수에 따라 주변 모든 병원을 보장하지는 않음</a:t>
             </a:r>
           </a:p>
           <a:p>
@@ -5106,7 +5106,7 @@
                 </a:solidFill>
                 <a:latin typeface="Malgun Gothic"/>
               </a:rPr>
-              <a:t>거리 계산 없음 — 기관 좌표 컬럼으로 실제 거리 정렬 가능 (v2에서 좌표·역지오코딩 진행 중)</a:t>
+              <a:t>거리·경로 안내 부족 — 좌표 기반 거리순 정렬과 지도 API 경로 안내가 다음 개선점</a:t>
             </a:r>
           </a:p>
           <a:p>

</xml_diff>